<commit_message>
docs: sync deck and jury Q&A with the updated screens.json (73.3% -> 54.0%)
The A2 dataset expansion landed after E3's deck/doc pass, leaving both
citing a now-stale 73.3%/96-site figure. Fixed at the source rather than
hand-editing the number: build_deck.py's site count and the "+pts vs
zero-shot" delta were hardcoded strings — now derived from
screens.json's own protocol string and accuracy fields, so this can't
drift out of sync again. Regenerated the .pptx. Rewrote JURY_QA.md's
Q10 with the real 54.0%/235-screen/115-site numbers and why the drop is
a genuine finding (fold-independent zero-shot baseline dropped too, and
every new capture was hand-verified before retraining) rather than a
fold-shuffle or labeling artifact.
</commit_message>
<xml_diff>
--- a/docs/deck/Aavaran_SIH2026_PS26171.pptx
+++ b/docs/deck/Aavaran_SIH2026_PS26171.pptx
@@ -242,10 +242,10 @@
                 <c:formatCode>General</c:formatCode>
                 <c:ptCount val="2"/>
                 <c:pt idx="0">
-                  <c:v>0.558</c:v>
+                  <c:v>0.391</c:v>
                 </c:pt>
                 <c:pt idx="1">
-                  <c:v>0.733</c:v>
+                  <c:v>0.54</c:v>
                 </c:pt>
               </c:numCache>
             </c:numRef>
@@ -7219,7 +7219,7 @@
                 </a:solidFill>
                 <a:latin typeface="Calibri"/>
               </a:rPr>
-              <a:t>a ViT fused with DOM structure understands unseen websites 73.3% vs 55.8% from pixels alone.</a:t>
+              <a:t>a ViT fused with DOM structure understands unseen websites 54.0% vs 39.1% from pixels alone.</a:t>
             </a:r>
           </a:p>
           <a:p>
@@ -10318,7 +10318,7 @@
                 </a:solidFill>
                 <a:latin typeface="Cambria"/>
               </a:rPr>
-              <a:t>73.3%</a:t>
+              <a:t>54.0%</a:t>
             </a:r>
           </a:p>
         </p:txBody>
@@ -10365,7 +10365,7 @@
                 </a:solidFill>
                 <a:latin typeface="Calibri"/>
               </a:rPr>
-              <a:t>unseen websites (96 sites)</a:t>
+              <a:t>unseen websites (? sites)</a:t>
             </a:r>
           </a:p>
         </p:txBody>
@@ -11397,7 +11397,7 @@
                           </a:solidFill>
                           <a:latin typeface="Calibri"/>
                         </a:rPr>
-                        <a:t>Fuse pixels with DOM structure (+17.5 pts on unseen sites); element grounding via DOM + Set-of-Marks is exact</a:t>
+                        <a:t>Fuse pixels with DOM structure (+14.9 pts on unseen sites); element grounding via DOM + Set-of-Marks is exact</a:t>
                       </a:r>
                     </a:p>
                   </a:txBody>

</xml_diff>